<commit_message>
Added PWM Setup and adjusted PID and Mathematical Model as necessary
</commit_message>
<xml_diff>
--- a/fall_2025/Mathematical Model/Flight Controls Mathematical Model.pptx
+++ b/fall_2025/Mathematical Model/Flight Controls Mathematical Model.pptx
@@ -926,10 +926,25 @@
   <pc:docChgLst>
     <pc:chgData name="Brady Schick" userId="b2b33ab7-3f5f-4057-91d3-3d23bb8ba623" providerId="ADAL" clId="{119C1645-25BF-4125-9DBD-47C0423EEB24}"/>
     <pc:docChg chg="custSel addSld modSld">
-      <pc:chgData name="Brady Schick" userId="b2b33ab7-3f5f-4057-91d3-3d23bb8ba623" providerId="ADAL" clId="{119C1645-25BF-4125-9DBD-47C0423EEB24}" dt="2025-09-26T15:26:38.097" v="381" actId="20577"/>
+      <pc:chgData name="Brady Schick" userId="b2b33ab7-3f5f-4057-91d3-3d23bb8ba623" providerId="ADAL" clId="{119C1645-25BF-4125-9DBD-47C0423EEB24}" dt="2025-10-02T19:15:47.384" v="673"/>
       <pc:docMkLst>
         <pc:docMk/>
       </pc:docMkLst>
+      <pc:sldChg chg="modSp mod">
+        <pc:chgData name="Brady Schick" userId="b2b33ab7-3f5f-4057-91d3-3d23bb8ba623" providerId="ADAL" clId="{119C1645-25BF-4125-9DBD-47C0423EEB24}" dt="2025-10-02T19:14:21.614" v="534" actId="6549"/>
+        <pc:sldMkLst>
+          <pc:docMk/>
+          <pc:sldMk cId="4271143265" sldId="257"/>
+        </pc:sldMkLst>
+        <pc:spChg chg="mod">
+          <ac:chgData name="Brady Schick" userId="b2b33ab7-3f5f-4057-91d3-3d23bb8ba623" providerId="ADAL" clId="{119C1645-25BF-4125-9DBD-47C0423EEB24}" dt="2025-10-02T19:14:21.614" v="534" actId="6549"/>
+          <ac:spMkLst>
+            <pc:docMk/>
+            <pc:sldMk cId="4271143265" sldId="257"/>
+            <ac:spMk id="3" creationId="{6D5E60D6-9EBD-1A61-B20C-576B5403A52F}"/>
+          </ac:spMkLst>
+        </pc:spChg>
+      </pc:sldChg>
       <pc:sldChg chg="modSp mod">
         <pc:chgData name="Brady Schick" userId="b2b33ab7-3f5f-4057-91d3-3d23bb8ba623" providerId="ADAL" clId="{119C1645-25BF-4125-9DBD-47C0423EEB24}" dt="2025-09-26T15:26:38.097" v="381" actId="20577"/>
         <pc:sldMkLst>
@@ -945,8 +960,53 @@
           </ac:spMkLst>
         </pc:spChg>
       </pc:sldChg>
+      <pc:sldChg chg="modSp mod">
+        <pc:chgData name="Brady Schick" userId="b2b33ab7-3f5f-4057-91d3-3d23bb8ba623" providerId="ADAL" clId="{119C1645-25BF-4125-9DBD-47C0423EEB24}" dt="2025-10-02T19:11:08.199" v="393" actId="20577"/>
+        <pc:sldMkLst>
+          <pc:docMk/>
+          <pc:sldMk cId="3399213682" sldId="264"/>
+        </pc:sldMkLst>
+        <pc:spChg chg="mod">
+          <ac:chgData name="Brady Schick" userId="b2b33ab7-3f5f-4057-91d3-3d23bb8ba623" providerId="ADAL" clId="{119C1645-25BF-4125-9DBD-47C0423EEB24}" dt="2025-10-02T19:11:08.199" v="393" actId="20577"/>
+          <ac:spMkLst>
+            <pc:docMk/>
+            <pc:sldMk cId="3399213682" sldId="264"/>
+            <ac:spMk id="3" creationId="{6D5E60D6-9EBD-1A61-B20C-576B5403A52F}"/>
+          </ac:spMkLst>
+        </pc:spChg>
+      </pc:sldChg>
+      <pc:sldChg chg="modSp mod">
+        <pc:chgData name="Brady Schick" userId="b2b33ab7-3f5f-4057-91d3-3d23bb8ba623" providerId="ADAL" clId="{119C1645-25BF-4125-9DBD-47C0423EEB24}" dt="2025-10-02T19:15:27.516" v="662" actId="20577"/>
+        <pc:sldMkLst>
+          <pc:docMk/>
+          <pc:sldMk cId="92075563" sldId="265"/>
+        </pc:sldMkLst>
+        <pc:spChg chg="mod">
+          <ac:chgData name="Brady Schick" userId="b2b33ab7-3f5f-4057-91d3-3d23bb8ba623" providerId="ADAL" clId="{119C1645-25BF-4125-9DBD-47C0423EEB24}" dt="2025-10-02T19:15:27.516" v="662" actId="20577"/>
+          <ac:spMkLst>
+            <pc:docMk/>
+            <pc:sldMk cId="92075563" sldId="265"/>
+            <ac:spMk id="3" creationId="{6D5E60D6-9EBD-1A61-B20C-576B5403A52F}"/>
+          </ac:spMkLst>
+        </pc:spChg>
+      </pc:sldChg>
+      <pc:sldChg chg="modSp mod">
+        <pc:chgData name="Brady Schick" userId="b2b33ab7-3f5f-4057-91d3-3d23bb8ba623" providerId="ADAL" clId="{119C1645-25BF-4125-9DBD-47C0423EEB24}" dt="2025-10-02T19:15:47.384" v="673"/>
+        <pc:sldMkLst>
+          <pc:docMk/>
+          <pc:sldMk cId="3786574737" sldId="267"/>
+        </pc:sldMkLst>
+        <pc:spChg chg="mod">
+          <ac:chgData name="Brady Schick" userId="b2b33ab7-3f5f-4057-91d3-3d23bb8ba623" providerId="ADAL" clId="{119C1645-25BF-4125-9DBD-47C0423EEB24}" dt="2025-10-02T19:15:47.384" v="673"/>
+          <ac:spMkLst>
+            <pc:docMk/>
+            <pc:sldMk cId="3786574737" sldId="267"/>
+            <ac:spMk id="3" creationId="{6D5E60D6-9EBD-1A61-B20C-576B5403A52F}"/>
+          </ac:spMkLst>
+        </pc:spChg>
+      </pc:sldChg>
       <pc:sldChg chg="modSp add mod">
-        <pc:chgData name="Brady Schick" userId="b2b33ab7-3f5f-4057-91d3-3d23bb8ba623" providerId="ADAL" clId="{119C1645-25BF-4125-9DBD-47C0423EEB24}" dt="2025-09-25T12:45:02.581" v="305" actId="20577"/>
+        <pc:chgData name="Brady Schick" userId="b2b33ab7-3f5f-4057-91d3-3d23bb8ba623" providerId="ADAL" clId="{119C1645-25BF-4125-9DBD-47C0423EEB24}" dt="2025-10-02T19:15:08.069" v="656" actId="20577"/>
         <pc:sldMkLst>
           <pc:docMk/>
           <pc:sldMk cId="2499484992" sldId="268"/>
@@ -960,7 +1020,7 @@
           </ac:spMkLst>
         </pc:spChg>
         <pc:spChg chg="mod">
-          <ac:chgData name="Brady Schick" userId="b2b33ab7-3f5f-4057-91d3-3d23bb8ba623" providerId="ADAL" clId="{119C1645-25BF-4125-9DBD-47C0423EEB24}" dt="2025-09-25T12:45:02.581" v="305" actId="20577"/>
+          <ac:chgData name="Brady Schick" userId="b2b33ab7-3f5f-4057-91d3-3d23bb8ba623" providerId="ADAL" clId="{119C1645-25BF-4125-9DBD-47C0423EEB24}" dt="2025-10-02T19:15:08.069" v="656" actId="20577"/>
           <ac:spMkLst>
             <pc:docMk/>
             <pc:sldMk cId="2499484992" sldId="268"/>
@@ -1364,7 +1424,7 @@
           <a:p>
             <a:fld id="{CCE55368-DE8C-481A-9FFC-45CFE5380273}" type="datetimeFigureOut">
               <a:rPr lang="en-US" smtClean="0"/>
-              <a:t>9/26/2025</a:t>
+              <a:t>10/2/2025</a:t>
             </a:fld>
             <a:endParaRPr lang="en-US"/>
           </a:p>
@@ -1562,7 +1622,7 @@
           <a:p>
             <a:fld id="{CCE55368-DE8C-481A-9FFC-45CFE5380273}" type="datetimeFigureOut">
               <a:rPr lang="en-US" smtClean="0"/>
-              <a:t>9/26/2025</a:t>
+              <a:t>10/2/2025</a:t>
             </a:fld>
             <a:endParaRPr lang="en-US"/>
           </a:p>
@@ -1770,7 +1830,7 @@
           <a:p>
             <a:fld id="{CCE55368-DE8C-481A-9FFC-45CFE5380273}" type="datetimeFigureOut">
               <a:rPr lang="en-US" smtClean="0"/>
-              <a:t>9/26/2025</a:t>
+              <a:t>10/2/2025</a:t>
             </a:fld>
             <a:endParaRPr lang="en-US"/>
           </a:p>
@@ -1968,7 +2028,7 @@
           <a:p>
             <a:fld id="{CCE55368-DE8C-481A-9FFC-45CFE5380273}" type="datetimeFigureOut">
               <a:rPr lang="en-US" smtClean="0"/>
-              <a:t>9/26/2025</a:t>
+              <a:t>10/2/2025</a:t>
             </a:fld>
             <a:endParaRPr lang="en-US"/>
           </a:p>
@@ -2243,7 +2303,7 @@
           <a:p>
             <a:fld id="{CCE55368-DE8C-481A-9FFC-45CFE5380273}" type="datetimeFigureOut">
               <a:rPr lang="en-US" smtClean="0"/>
-              <a:t>9/26/2025</a:t>
+              <a:t>10/2/2025</a:t>
             </a:fld>
             <a:endParaRPr lang="en-US"/>
           </a:p>
@@ -2508,7 +2568,7 @@
           <a:p>
             <a:fld id="{CCE55368-DE8C-481A-9FFC-45CFE5380273}" type="datetimeFigureOut">
               <a:rPr lang="en-US" smtClean="0"/>
-              <a:t>9/26/2025</a:t>
+              <a:t>10/2/2025</a:t>
             </a:fld>
             <a:endParaRPr lang="en-US"/>
           </a:p>
@@ -2920,7 +2980,7 @@
           <a:p>
             <a:fld id="{CCE55368-DE8C-481A-9FFC-45CFE5380273}" type="datetimeFigureOut">
               <a:rPr lang="en-US" smtClean="0"/>
-              <a:t>9/26/2025</a:t>
+              <a:t>10/2/2025</a:t>
             </a:fld>
             <a:endParaRPr lang="en-US"/>
           </a:p>
@@ -3061,7 +3121,7 @@
           <a:p>
             <a:fld id="{CCE55368-DE8C-481A-9FFC-45CFE5380273}" type="datetimeFigureOut">
               <a:rPr lang="en-US" smtClean="0"/>
-              <a:t>9/26/2025</a:t>
+              <a:t>10/2/2025</a:t>
             </a:fld>
             <a:endParaRPr lang="en-US"/>
           </a:p>
@@ -3174,7 +3234,7 @@
           <a:p>
             <a:fld id="{CCE55368-DE8C-481A-9FFC-45CFE5380273}" type="datetimeFigureOut">
               <a:rPr lang="en-US" smtClean="0"/>
-              <a:t>9/26/2025</a:t>
+              <a:t>10/2/2025</a:t>
             </a:fld>
             <a:endParaRPr lang="en-US"/>
           </a:p>
@@ -3485,7 +3545,7 @@
           <a:p>
             <a:fld id="{CCE55368-DE8C-481A-9FFC-45CFE5380273}" type="datetimeFigureOut">
               <a:rPr lang="en-US" smtClean="0"/>
-              <a:t>9/26/2025</a:t>
+              <a:t>10/2/2025</a:t>
             </a:fld>
             <a:endParaRPr lang="en-US"/>
           </a:p>
@@ -3773,7 +3833,7 @@
           <a:p>
             <a:fld id="{CCE55368-DE8C-481A-9FFC-45CFE5380273}" type="datetimeFigureOut">
               <a:rPr lang="en-US" smtClean="0"/>
-              <a:t>9/26/2025</a:t>
+              <a:t>10/2/2025</a:t>
             </a:fld>
             <a:endParaRPr lang="en-US"/>
           </a:p>
@@ -4014,7 +4074,7 @@
           <a:p>
             <a:fld id="{CCE55368-DE8C-481A-9FFC-45CFE5380273}" type="datetimeFigureOut">
               <a:rPr lang="en-US" smtClean="0"/>
-              <a:t>9/26/2025</a:t>
+              <a:t>10/2/2025</a:t>
             </a:fld>
             <a:endParaRPr lang="en-US"/>
           </a:p>
@@ -8180,7 +8240,15 @@
             <a:pPr lvl="1"/>
             <a:r>
               <a:rPr lang="en-US" sz="1800" dirty="0"/>
-              <a:t>Final output: gives the Duty Cycle of the PWM signal that needs to be generated (valued from 0 to 100)</a:t>
+              <a:t>Final output: gives the Duty Cycle of the PWM signal that needs to be generated (valued from 0 to 255, NOT 100. Because that’s the way the 8-bit-resolution-pwm-cookie crème </a:t>
+            </a:r>
+            <a:r>
+              <a:rPr lang="en-US" sz="1800" dirty="0" err="1"/>
+              <a:t>brûlées</a:t>
+            </a:r>
+            <a:r>
+              <a:rPr lang="en-US" sz="1800" dirty="0"/>
+              <a:t>)</a:t>
             </a:r>
           </a:p>
           <a:p>
@@ -8349,7 +8417,7 @@
             </a:r>
             <a:r>
               <a:rPr lang="en-US" dirty="0"/>
-              <a:t> &gt; 100) {</a:t>
+              <a:t> &gt; 255) {</a:t>
             </a:r>
           </a:p>
           <a:p>
@@ -8366,7 +8434,7 @@
             </a:r>
             <a:r>
               <a:rPr lang="en-US" dirty="0"/>
-              <a:t> = 100;</a:t>
+              <a:t> = 255;</a:t>
             </a:r>
           </a:p>
           <a:p>
@@ -8881,8 +8949,8 @@
           </a:p>
         </p:txBody>
       </p:sp>
-      <mc:AlternateContent xmlns:mc="http://schemas.openxmlformats.org/markup-compatibility/2006" xmlns:a14="http://schemas.microsoft.com/office/drawing/2010/main">
-        <mc:Choice Requires="a14">
+      <mc:AlternateContent xmlns:mc="http://schemas.openxmlformats.org/markup-compatibility/2006">
+        <mc:Choice xmlns:a14="http://schemas.microsoft.com/office/drawing/2010/main" Requires="a14">
           <p:sp>
             <p:nvSpPr>
               <p:cNvPr id="3" name="Content Placeholder 2">
@@ -8902,7 +8970,7 @@
             <p:spPr/>
             <p:txBody>
               <a:bodyPr>
-                <a:normAutofit fontScale="92500"/>
+                <a:normAutofit fontScale="85000" lnSpcReduction="10000"/>
               </a:bodyPr>
               <a:lstStyle/>
               <a:p>
@@ -9415,18 +9483,22 @@
                 </a:pPr>
                 <a:r>
                   <a:rPr lang="en-US" dirty="0"/>
-                  <a:t>NOTE: I didn’t simplify the 2b, because the 2 coefficient will not change with the 2 in </a:t>
+                  <a:t>NOTE: I didn’t simplify the 2b, because the 2 coefficient will not change with the 2 in the denominator.</a:t>
                 </a:r>
+              </a:p>
+              <a:p>
+                <a:pPr marL="0" indent="0">
+                  <a:buNone/>
+                </a:pPr>
                 <a:r>
-                  <a:rPr lang="en-US"/>
-                  <a:t>the denominator.</a:t>
+                  <a:rPr lang="en-US" dirty="0"/>
+                  <a:t>Other note: forget this stuff, we’ll just average and filter before sending the error to the function.</a:t>
                 </a:r>
-                <a:endParaRPr lang="en-US" dirty="0"/>
               </a:p>
             </p:txBody>
           </p:sp>
         </mc:Choice>
-        <mc:Fallback xmlns="">
+        <mc:Fallback>
           <p:sp>
             <p:nvSpPr>
               <p:cNvPr id="3" name="Content Placeholder 2">
@@ -9447,7 +9519,7 @@
               <a:blipFill>
                 <a:blip r:embed="rId2"/>
                 <a:stretch>
-                  <a:fillRect l="-1043" t="-2101" b="-2381"/>
+                  <a:fillRect l="-928" t="-2521" r="-1333"/>
                 </a:stretch>
               </a:blipFill>
             </p:spPr>
@@ -9602,7 +9674,7 @@
           <a:p>
             <a:r>
               <a:rPr lang="en-US" dirty="0"/>
-              <a:t>100 would work but we could probably cap it at a smaller value.</a:t>
+              <a:t>255 would work but we could probably cap it at a smaller value.</a:t>
             </a:r>
           </a:p>
         </p:txBody>
@@ -9824,7 +9896,15 @@
             </a:pPr>
             <a:r>
               <a:rPr lang="en-US" dirty="0"/>
-              <a:t>This should keep the final Duty Cycle values between 0 and 100</a:t>
+              <a:t>This should keep the final values between 0 and 255 (crème </a:t>
+            </a:r>
+            <a:r>
+              <a:rPr lang="en-US" dirty="0" err="1"/>
+              <a:t>brûlée</a:t>
+            </a:r>
+            <a:r>
+              <a:rPr lang="en-US" dirty="0"/>
+              <a:t>)</a:t>
             </a:r>
           </a:p>
           <a:p>

</xml_diff>